<commit_message>
docs: sync tool count to 6, repo links to renamed repo, add browse_catalogue to deck
- README/LinkedIn/deck: 5 -> 6 tools; deck tools slide gains the
  browse_catalogue row (layout retightened, footer clear, validated)
- repo links drop the trailing hyphen (repo was renamed to minhtak-assistant)
</commit_message>
<xml_diff>
--- a/docs/minhtak-assistant-presentation.pptx
+++ b/docs/minhtak-assistant-presentation.pptx
@@ -3701,7 +3701,7 @@
                 <a:ea typeface="Calibri" pitchFamily="34" charset="-122"/>
                 <a:cs typeface="Calibri" pitchFamily="34" charset="-120"/>
               </a:rPr>
-              <a:t>5 tools, Gemini function calling in AUTO mode. The model chooses and chains.</a:t>
+              <a:t>6 tools, Gemini function calling in AUTO mode. The model chooses and chains.</a:t>
             </a:r>
             <a:endParaRPr lang="en-US" sz="1300" dirty="0"/>
           </a:p>
@@ -4411,7 +4411,7 @@
                 <a:ea typeface="Cambria" pitchFamily="34" charset="-122"/>
                 <a:cs typeface="Cambria" pitchFamily="34" charset="-120"/>
               </a:rPr>
-              <a:t>CHOSEN — one agent, five tools</a:t>
+              <a:t>CHOSEN — one agent, six tools</a:t>
             </a:r>
             <a:endParaRPr lang="en-US" sz="1500" dirty="0"/>
           </a:p>
@@ -4639,7 +4639,7 @@
                 <a:ea typeface="Cambria" pitchFamily="34" charset="-122"/>
                 <a:cs typeface="Cambria" pitchFamily="34" charset="-120"/>
               </a:rPr>
-              <a:t>The five tools</a:t>
+              <a:t>The six tools</a:t>
             </a:r>
             <a:endParaRPr lang="en-US" sz="3400" dirty="0"/>
           </a:p>
@@ -4653,12 +4653,12 @@
         </p:nvSpPr>
         <p:spPr>
           <a:xfrm>
-            <a:off x="640080" y="1371600"/>
-            <a:ext cx="10881360" cy="777240"/>
+            <a:off x="640080" y="1325880"/>
+            <a:ext cx="10881360" cy="621792"/>
           </a:xfrm>
           <a:prstGeom prst="roundRect">
             <a:avLst>
-              <a:gd name="adj" fmla="val 14118"/>
+              <a:gd name="adj" fmla="val 17647"/>
             </a:avLst>
           </a:prstGeom>
           <a:solidFill>
@@ -4687,8 +4687,8 @@
         </p:nvSpPr>
         <p:spPr>
           <a:xfrm>
-            <a:off x="960120" y="1572768"/>
-            <a:ext cx="3840480" cy="365760"/>
+            <a:off x="960120" y="1463040"/>
+            <a:ext cx="3931920" cy="365760"/>
           </a:xfrm>
           <a:prstGeom prst="rect">
             <a:avLst/>
@@ -4704,7 +4704,7 @@
               <a:buNone/>
             </a:pPr>
             <a:r>
-              <a:rPr lang="en-US" sz="1500" b="1" dirty="0">
+              <a:rPr lang="en-US" sz="1400" b="1" dirty="0">
                 <a:solidFill>
                   <a:srgbClr val="0F766E"/>
                 </a:solidFill>
@@ -4714,7 +4714,7 @@
               </a:rPr>
               <a:t>search_scholarships</a:t>
             </a:r>
-            <a:endParaRPr lang="en-US" sz="1500" dirty="0"/>
+            <a:endParaRPr lang="en-US" sz="1400" dirty="0"/>
           </a:p>
         </p:txBody>
       </p:sp>
@@ -4726,8 +4726,8 @@
         </p:nvSpPr>
         <p:spPr>
           <a:xfrm>
-            <a:off x="4937760" y="1572768"/>
-            <a:ext cx="3931920" cy="365760"/>
+            <a:off x="5029200" y="1463040"/>
+            <a:ext cx="3840480" cy="365760"/>
           </a:xfrm>
           <a:prstGeom prst="rect">
             <a:avLst/>
@@ -4743,7 +4743,7 @@
               <a:buNone/>
             </a:pPr>
             <a:r>
-              <a:rPr lang="en-US" sz="1400" dirty="0">
+              <a:rPr lang="en-US" sz="1300" dirty="0">
                 <a:solidFill>
                   <a:srgbClr val="0E1116"/>
                 </a:solidFill>
@@ -4753,7 +4753,7 @@
               </a:rPr>
               <a:t>Ranked matches for a student profile</a:t>
             </a:r>
-            <a:endParaRPr lang="en-US" sz="1400" dirty="0"/>
+            <a:endParaRPr lang="en-US" sz="1300" dirty="0"/>
           </a:p>
         </p:txBody>
       </p:sp>
@@ -4765,7 +4765,7 @@
         </p:nvSpPr>
         <p:spPr>
           <a:xfrm>
-            <a:off x="8961120" y="1572768"/>
+            <a:off x="8961120" y="1463040"/>
             <a:ext cx="2286000" cy="365760"/>
           </a:xfrm>
           <a:prstGeom prst="rect">
@@ -4782,7 +4782,7 @@
               <a:buNone/>
             </a:pPr>
             <a:r>
-              <a:rPr lang="en-US" sz="1200" dirty="0">
+              <a:rPr lang="en-US" sz="1100" dirty="0">
                 <a:solidFill>
                   <a:srgbClr val="5C6672"/>
                 </a:solidFill>
@@ -4792,7 +4792,7 @@
               </a:rPr>
               <a:t>Live minhtak API</a:t>
             </a:r>
-            <a:endParaRPr lang="en-US" sz="1200" dirty="0"/>
+            <a:endParaRPr lang="en-US" sz="1100" dirty="0"/>
           </a:p>
         </p:txBody>
       </p:sp>
@@ -4804,12 +4804,12 @@
         </p:nvSpPr>
         <p:spPr>
           <a:xfrm>
-            <a:off x="640080" y="2286000"/>
-            <a:ext cx="10881360" cy="777240"/>
+            <a:off x="640080" y="2075688"/>
+            <a:ext cx="10881360" cy="621792"/>
           </a:xfrm>
           <a:prstGeom prst="roundRect">
             <a:avLst>
-              <a:gd name="adj" fmla="val 14118"/>
+              <a:gd name="adj" fmla="val 17647"/>
             </a:avLst>
           </a:prstGeom>
           <a:solidFill>
@@ -4838,8 +4838,8 @@
         </p:nvSpPr>
         <p:spPr>
           <a:xfrm>
-            <a:off x="960120" y="2487168"/>
-            <a:ext cx="3840480" cy="365760"/>
+            <a:off x="960120" y="2212848"/>
+            <a:ext cx="3931920" cy="365760"/>
           </a:xfrm>
           <a:prstGeom prst="rect">
             <a:avLst/>
@@ -4855,7 +4855,7 @@
               <a:buNone/>
             </a:pPr>
             <a:r>
-              <a:rPr lang="en-US" sz="1500" b="1" dirty="0">
+              <a:rPr lang="en-US" sz="1400" b="1" dirty="0">
                 <a:solidFill>
                   <a:srgbClr val="0F766E"/>
                 </a:solidFill>
@@ -4863,9 +4863,9 @@
                 <a:ea typeface="Courier New" pitchFamily="34" charset="-122"/>
                 <a:cs typeface="Courier New" pitchFamily="34" charset="-120"/>
               </a:rPr>
-              <a:t>get_scholarship_details</a:t>
-            </a:r>
-            <a:endParaRPr lang="en-US" sz="1500" dirty="0"/>
+              <a:t>browse_catalogue</a:t>
+            </a:r>
+            <a:endParaRPr lang="en-US" sz="1400" dirty="0"/>
           </a:p>
         </p:txBody>
       </p:sp>
@@ -4877,8 +4877,8 @@
         </p:nvSpPr>
         <p:spPr>
           <a:xfrm>
-            <a:off x="4937760" y="2487168"/>
-            <a:ext cx="3931920" cy="365760"/>
+            <a:off x="5029200" y="2212848"/>
+            <a:ext cx="3840480" cy="365760"/>
           </a:xfrm>
           <a:prstGeom prst="rect">
             <a:avLst/>
@@ -4894,7 +4894,7 @@
               <a:buNone/>
             </a:pPr>
             <a:r>
-              <a:rPr lang="en-US" sz="1400" dirty="0">
+              <a:rPr lang="en-US" sz="1300" dirty="0">
                 <a:solidFill>
                   <a:srgbClr val="0E1116"/>
                 </a:solidFill>
@@ -4902,9 +4902,9 @@
                 <a:ea typeface="Calibri" pitchFamily="34" charset="-122"/>
                 <a:cs typeface="Calibri" pitchFamily="34" charset="-120"/>
               </a:rPr>
-              <a:t>Funding, all deadlines, official link</a:t>
-            </a:r>
-            <a:endParaRPr lang="en-US" sz="1400" dirty="0"/>
+              <a:t>Look up a scholarship by name; list a country</a:t>
+            </a:r>
+            <a:endParaRPr lang="en-US" sz="1300" dirty="0"/>
           </a:p>
         </p:txBody>
       </p:sp>
@@ -4916,7 +4916,7 @@
         </p:nvSpPr>
         <p:spPr>
           <a:xfrm>
-            <a:off x="8961120" y="2487168"/>
+            <a:off x="8961120" y="2212848"/>
             <a:ext cx="2286000" cy="365760"/>
           </a:xfrm>
           <a:prstGeom prst="rect">
@@ -4933,7 +4933,7 @@
               <a:buNone/>
             </a:pPr>
             <a:r>
-              <a:rPr lang="en-US" sz="1200" dirty="0">
+              <a:rPr lang="en-US" sz="1100" dirty="0">
                 <a:solidFill>
                   <a:srgbClr val="5C6672"/>
                 </a:solidFill>
@@ -4943,7 +4943,7 @@
               </a:rPr>
               <a:t>Live minhtak API</a:t>
             </a:r>
-            <a:endParaRPr lang="en-US" sz="1200" dirty="0"/>
+            <a:endParaRPr lang="en-US" sz="1100" dirty="0"/>
           </a:p>
         </p:txBody>
       </p:sp>
@@ -4955,12 +4955,12 @@
         </p:nvSpPr>
         <p:spPr>
           <a:xfrm>
-            <a:off x="640080" y="3200400"/>
-            <a:ext cx="10881360" cy="777240"/>
+            <a:off x="640080" y="2825496"/>
+            <a:ext cx="10881360" cy="621792"/>
           </a:xfrm>
           <a:prstGeom prst="roundRect">
             <a:avLst>
-              <a:gd name="adj" fmla="val 14118"/>
+              <a:gd name="adj" fmla="val 17647"/>
             </a:avLst>
           </a:prstGeom>
           <a:solidFill>
@@ -4989,8 +4989,8 @@
         </p:nvSpPr>
         <p:spPr>
           <a:xfrm>
-            <a:off x="960120" y="3401568"/>
-            <a:ext cx="3840480" cy="365760"/>
+            <a:off x="960120" y="2962656"/>
+            <a:ext cx="3931920" cy="365760"/>
           </a:xfrm>
           <a:prstGeom prst="rect">
             <a:avLst/>
@@ -5006,7 +5006,7 @@
               <a:buNone/>
             </a:pPr>
             <a:r>
-              <a:rPr lang="en-US" sz="1500" b="1" dirty="0">
+              <a:rPr lang="en-US" sz="1400" b="1" dirty="0">
                 <a:solidFill>
                   <a:srgbClr val="0F766E"/>
                 </a:solidFill>
@@ -5014,9 +5014,9 @@
                 <a:ea typeface="Courier New" pitchFamily="34" charset="-122"/>
                 <a:cs typeface="Courier New" pitchFamily="34" charset="-120"/>
               </a:rPr>
-              <a:t>search_uploaded_documents</a:t>
-            </a:r>
-            <a:endParaRPr lang="en-US" sz="1500" dirty="0"/>
+              <a:t>get_scholarship_details</a:t>
+            </a:r>
+            <a:endParaRPr lang="en-US" sz="1400" dirty="0"/>
           </a:p>
         </p:txBody>
       </p:sp>
@@ -5028,8 +5028,8 @@
         </p:nvSpPr>
         <p:spPr>
           <a:xfrm>
-            <a:off x="4937760" y="3401568"/>
-            <a:ext cx="3931920" cy="365760"/>
+            <a:off x="5029200" y="2962656"/>
+            <a:ext cx="3840480" cy="365760"/>
           </a:xfrm>
           <a:prstGeom prst="rect">
             <a:avLst/>
@@ -5045,7 +5045,7 @@
               <a:buNone/>
             </a:pPr>
             <a:r>
-              <a:rPr lang="en-US" sz="1400" dirty="0">
+              <a:rPr lang="en-US" sz="1300" dirty="0">
                 <a:solidFill>
                   <a:srgbClr val="0E1116"/>
                 </a:solidFill>
@@ -5053,9 +5053,9 @@
                 <a:ea typeface="Calibri" pitchFamily="34" charset="-122"/>
                 <a:cs typeface="Calibri" pitchFamily="34" charset="-120"/>
               </a:rPr>
-              <a:t>Top-k passages from your PDFs</a:t>
-            </a:r>
-            <a:endParaRPr lang="en-US" sz="1400" dirty="0"/>
+              <a:t>Funding, all deadlines, official link</a:t>
+            </a:r>
+            <a:endParaRPr lang="en-US" sz="1300" dirty="0"/>
           </a:p>
         </p:txBody>
       </p:sp>
@@ -5067,7 +5067,7 @@
         </p:nvSpPr>
         <p:spPr>
           <a:xfrm>
-            <a:off x="8961120" y="3401568"/>
+            <a:off x="8961120" y="2962656"/>
             <a:ext cx="2286000" cy="365760"/>
           </a:xfrm>
           <a:prstGeom prst="rect">
@@ -5084,7 +5084,7 @@
               <a:buNone/>
             </a:pPr>
             <a:r>
-              <a:rPr lang="en-US" sz="1200" dirty="0">
+              <a:rPr lang="en-US" sz="1100" dirty="0">
                 <a:solidFill>
                   <a:srgbClr val="5C6672"/>
                 </a:solidFill>
@@ -5092,9 +5092,9 @@
                 <a:ea typeface="Calibri" pitchFamily="34" charset="-122"/>
                 <a:cs typeface="Calibri" pitchFamily="34" charset="-120"/>
               </a:rPr>
-              <a:t>This session's RAG index</a:t>
-            </a:r>
-            <a:endParaRPr lang="en-US" sz="1200" dirty="0"/>
+              <a:t>Live minhtak API</a:t>
+            </a:r>
+            <a:endParaRPr lang="en-US" sz="1100" dirty="0"/>
           </a:p>
         </p:txBody>
       </p:sp>
@@ -5106,12 +5106,12 @@
         </p:nvSpPr>
         <p:spPr>
           <a:xfrm>
-            <a:off x="640080" y="4114800"/>
-            <a:ext cx="10881360" cy="777240"/>
+            <a:off x="640080" y="3575304"/>
+            <a:ext cx="10881360" cy="621792"/>
           </a:xfrm>
           <a:prstGeom prst="roundRect">
             <a:avLst>
-              <a:gd name="adj" fmla="val 14118"/>
+              <a:gd name="adj" fmla="val 17647"/>
             </a:avLst>
           </a:prstGeom>
           <a:solidFill>
@@ -5140,8 +5140,8 @@
         </p:nvSpPr>
         <p:spPr>
           <a:xfrm>
-            <a:off x="960120" y="4315968"/>
-            <a:ext cx="3840480" cy="365760"/>
+            <a:off x="960120" y="3712464"/>
+            <a:ext cx="3931920" cy="365760"/>
           </a:xfrm>
           <a:prstGeom prst="rect">
             <a:avLst/>
@@ -5157,7 +5157,7 @@
               <a:buNone/>
             </a:pPr>
             <a:r>
-              <a:rPr lang="en-US" sz="1500" b="1" dirty="0">
+              <a:rPr lang="en-US" sz="1400" b="1" dirty="0">
                 <a:solidFill>
                   <a:srgbClr val="0F766E"/>
                 </a:solidFill>
@@ -5165,9 +5165,9 @@
                 <a:ea typeface="Courier New" pitchFamily="34" charset="-122"/>
                 <a:cs typeface="Courier New" pitchFamily="34" charset="-120"/>
               </a:rPr>
-              <a:t>get_weather</a:t>
-            </a:r>
-            <a:endParaRPr lang="en-US" sz="1500" dirty="0"/>
+              <a:t>search_uploaded_documents</a:t>
+            </a:r>
+            <a:endParaRPr lang="en-US" sz="1400" dirty="0"/>
           </a:p>
         </p:txBody>
       </p:sp>
@@ -5179,8 +5179,8 @@
         </p:nvSpPr>
         <p:spPr>
           <a:xfrm>
-            <a:off x="4937760" y="4315968"/>
-            <a:ext cx="3931920" cy="365760"/>
+            <a:off x="5029200" y="3712464"/>
+            <a:ext cx="3840480" cy="365760"/>
           </a:xfrm>
           <a:prstGeom prst="rect">
             <a:avLst/>
@@ -5196,7 +5196,7 @@
               <a:buNone/>
             </a:pPr>
             <a:r>
-              <a:rPr lang="en-US" sz="1400" dirty="0">
+              <a:rPr lang="en-US" sz="1300" dirty="0">
                 <a:solidFill>
                   <a:srgbClr val="0E1116"/>
                 </a:solidFill>
@@ -5204,9 +5204,9 @@
                 <a:ea typeface="Calibri" pitchFamily="34" charset="-122"/>
                 <a:cs typeface="Calibri" pitchFamily="34" charset="-120"/>
               </a:rPr>
-              <a:t>Conditions in a study destination</a:t>
-            </a:r>
-            <a:endParaRPr lang="en-US" sz="1400" dirty="0"/>
+              <a:t>Top-k passages from your PDFs</a:t>
+            </a:r>
+            <a:endParaRPr lang="en-US" sz="1300" dirty="0"/>
           </a:p>
         </p:txBody>
       </p:sp>
@@ -5218,7 +5218,7 @@
         </p:nvSpPr>
         <p:spPr>
           <a:xfrm>
-            <a:off x="8961120" y="4315968"/>
+            <a:off x="8961120" y="3712464"/>
             <a:ext cx="2286000" cy="365760"/>
           </a:xfrm>
           <a:prstGeom prst="rect">
@@ -5235,7 +5235,7 @@
               <a:buNone/>
             </a:pPr>
             <a:r>
-              <a:rPr lang="en-US" sz="1200" dirty="0">
+              <a:rPr lang="en-US" sz="1100" dirty="0">
                 <a:solidFill>
                   <a:srgbClr val="5C6672"/>
                 </a:solidFill>
@@ -5243,9 +5243,9 @@
                 <a:ea typeface="Calibri" pitchFamily="34" charset="-122"/>
                 <a:cs typeface="Calibri" pitchFamily="34" charset="-120"/>
               </a:rPr>
-              <a:t>Open-Meteo</a:t>
-            </a:r>
-            <a:endParaRPr lang="en-US" sz="1200" dirty="0"/>
+              <a:t>This session's RAG index</a:t>
+            </a:r>
+            <a:endParaRPr lang="en-US" sz="1100" dirty="0"/>
           </a:p>
         </p:txBody>
       </p:sp>
@@ -5257,12 +5257,12 @@
         </p:nvSpPr>
         <p:spPr>
           <a:xfrm>
-            <a:off x="640080" y="5029200"/>
-            <a:ext cx="10881360" cy="777240"/>
+            <a:off x="640080" y="4325112"/>
+            <a:ext cx="10881360" cy="621792"/>
           </a:xfrm>
           <a:prstGeom prst="roundRect">
             <a:avLst>
-              <a:gd name="adj" fmla="val 14118"/>
+              <a:gd name="adj" fmla="val 17647"/>
             </a:avLst>
           </a:prstGeom>
           <a:solidFill>
@@ -5291,8 +5291,8 @@
         </p:nvSpPr>
         <p:spPr>
           <a:xfrm>
-            <a:off x="960120" y="5230368"/>
-            <a:ext cx="3840480" cy="365760"/>
+            <a:off x="960120" y="4462272"/>
+            <a:ext cx="3931920" cy="365760"/>
           </a:xfrm>
           <a:prstGeom prst="rect">
             <a:avLst/>
@@ -5308,7 +5308,7 @@
               <a:buNone/>
             </a:pPr>
             <a:r>
-              <a:rPr lang="en-US" sz="1500" b="1" dirty="0">
+              <a:rPr lang="en-US" sz="1400" b="1" dirty="0">
                 <a:solidFill>
                   <a:srgbClr val="0F766E"/>
                 </a:solidFill>
@@ -5316,9 +5316,9 @@
                 <a:ea typeface="Courier New" pitchFamily="34" charset="-122"/>
                 <a:cs typeface="Courier New" pitchFamily="34" charset="-120"/>
               </a:rPr>
-              <a:t>calculate</a:t>
-            </a:r>
-            <a:endParaRPr lang="en-US" sz="1500" dirty="0"/>
+              <a:t>get_weather</a:t>
+            </a:r>
+            <a:endParaRPr lang="en-US" sz="1400" dirty="0"/>
           </a:p>
         </p:txBody>
       </p:sp>
@@ -5330,8 +5330,8 @@
         </p:nvSpPr>
         <p:spPr>
           <a:xfrm>
-            <a:off x="4937760" y="5230368"/>
-            <a:ext cx="3931920" cy="365760"/>
+            <a:off x="5029200" y="4462272"/>
+            <a:ext cx="3840480" cy="365760"/>
           </a:xfrm>
           <a:prstGeom prst="rect">
             <a:avLst/>
@@ -5347,7 +5347,7 @@
               <a:buNone/>
             </a:pPr>
             <a:r>
-              <a:rPr lang="en-US" sz="1400" dirty="0">
+              <a:rPr lang="en-US" sz="1300" dirty="0">
                 <a:solidFill>
                   <a:srgbClr val="0E1116"/>
                 </a:solidFill>
@@ -5355,9 +5355,9 @@
                 <a:ea typeface="Calibri" pitchFamily="34" charset="-122"/>
                 <a:cs typeface="Calibri" pitchFamily="34" charset="-120"/>
               </a:rPr>
-              <a:t>Safe arithmetic — AST walk, no eval</a:t>
-            </a:r>
-            <a:endParaRPr lang="en-US" sz="1400" dirty="0"/>
+              <a:t>Conditions in a study destination</a:t>
+            </a:r>
+            <a:endParaRPr lang="en-US" sz="1300" dirty="0"/>
           </a:p>
         </p:txBody>
       </p:sp>
@@ -5369,7 +5369,7 @@
         </p:nvSpPr>
         <p:spPr>
           <a:xfrm>
-            <a:off x="8961120" y="5230368"/>
+            <a:off x="8961120" y="4462272"/>
             <a:ext cx="2286000" cy="365760"/>
           </a:xfrm>
           <a:prstGeom prst="rect">
@@ -5386,7 +5386,7 @@
               <a:buNone/>
             </a:pPr>
             <a:r>
-              <a:rPr lang="en-US" sz="1200" dirty="0">
+              <a:rPr lang="en-US" sz="1100" dirty="0">
                 <a:solidFill>
                   <a:srgbClr val="5C6672"/>
                 </a:solidFill>
@@ -5394,21 +5394,172 @@
                 <a:ea typeface="Calibri" pitchFamily="34" charset="-122"/>
                 <a:cs typeface="Calibri" pitchFamily="34" charset="-120"/>
               </a:rPr>
+              <a:t>Open-Meteo</a:t>
+            </a:r>
+            <a:endParaRPr lang="en-US" sz="1100" dirty="0"/>
+          </a:p>
+        </p:txBody>
+      </p:sp>
+      <p:sp>
+        <p:nvSpPr>
+          <p:cNvPr id="23" name="Shape 21"/>
+          <p:cNvSpPr/>
+          <p:nvPr/>
+        </p:nvSpPr>
+        <p:spPr>
+          <a:xfrm>
+            <a:off x="640080" y="5074920"/>
+            <a:ext cx="10881360" cy="621792"/>
+          </a:xfrm>
+          <a:prstGeom prst="roundRect">
+            <a:avLst>
+              <a:gd name="adj" fmla="val 17647"/>
+            </a:avLst>
+          </a:prstGeom>
+          <a:solidFill>
+            <a:srgbClr val="FFFFFF"/>
+          </a:solidFill>
+          <a:ln w="12700">
+            <a:solidFill>
+              <a:srgbClr val="E3E6EA"/>
+            </a:solidFill>
+            <a:prstDash val="solid"/>
+          </a:ln>
+          <a:effectLst>
+            <a:outerShdw sx="100000" sy="100000" kx="0" ky="0" algn="bl" rotWithShape="0" blurRad="127000" dist="25400" dir="5400000">
+              <a:srgbClr val="9AA5B1">
+                <a:alpha val="25000"/>
+              </a:srgbClr>
+            </a:outerShdw>
+          </a:effectLst>
+        </p:spPr>
+      </p:sp>
+      <p:sp>
+        <p:nvSpPr>
+          <p:cNvPr id="24" name="Text 22"/>
+          <p:cNvSpPr/>
+          <p:nvPr/>
+        </p:nvSpPr>
+        <p:spPr>
+          <a:xfrm>
+            <a:off x="960120" y="5212080"/>
+            <a:ext cx="3931920" cy="365760"/>
+          </a:xfrm>
+          <a:prstGeom prst="rect">
+            <a:avLst/>
+          </a:prstGeom>
+          <a:noFill/>
+          <a:ln/>
+        </p:spPr>
+        <p:txBody>
+          <a:bodyPr wrap="square" lIns="0" tIns="0" rIns="0" bIns="0" rtlCol="0" anchor="ctr"/>
+          <a:lstStyle/>
+          <a:p>
+            <a:pPr indent="0" marL="0">
+              <a:buNone/>
+            </a:pPr>
+            <a:r>
+              <a:rPr lang="en-US" sz="1400" b="1" dirty="0">
+                <a:solidFill>
+                  <a:srgbClr val="0F766E"/>
+                </a:solidFill>
+                <a:latin typeface="Courier New" pitchFamily="34" charset="0"/>
+                <a:ea typeface="Courier New" pitchFamily="34" charset="-122"/>
+                <a:cs typeface="Courier New" pitchFamily="34" charset="-120"/>
+              </a:rPr>
+              <a:t>calculate</a:t>
+            </a:r>
+            <a:endParaRPr lang="en-US" sz="1400" dirty="0"/>
+          </a:p>
+        </p:txBody>
+      </p:sp>
+      <p:sp>
+        <p:nvSpPr>
+          <p:cNvPr id="25" name="Text 23"/>
+          <p:cNvSpPr/>
+          <p:nvPr/>
+        </p:nvSpPr>
+        <p:spPr>
+          <a:xfrm>
+            <a:off x="5029200" y="5212080"/>
+            <a:ext cx="3840480" cy="365760"/>
+          </a:xfrm>
+          <a:prstGeom prst="rect">
+            <a:avLst/>
+          </a:prstGeom>
+          <a:noFill/>
+          <a:ln/>
+        </p:spPr>
+        <p:txBody>
+          <a:bodyPr wrap="square" lIns="0" tIns="0" rIns="0" bIns="0" rtlCol="0" anchor="ctr"/>
+          <a:lstStyle/>
+          <a:p>
+            <a:pPr indent="0" marL="0">
+              <a:buNone/>
+            </a:pPr>
+            <a:r>
+              <a:rPr lang="en-US" sz="1300" dirty="0">
+                <a:solidFill>
+                  <a:srgbClr val="0E1116"/>
+                </a:solidFill>
+                <a:latin typeface="Calibri" pitchFamily="34" charset="0"/>
+                <a:ea typeface="Calibri" pitchFamily="34" charset="-122"/>
+                <a:cs typeface="Calibri" pitchFamily="34" charset="-120"/>
+              </a:rPr>
+              <a:t>Safe arithmetic — AST walk, no eval</a:t>
+            </a:r>
+            <a:endParaRPr lang="en-US" sz="1300" dirty="0"/>
+          </a:p>
+        </p:txBody>
+      </p:sp>
+      <p:sp>
+        <p:nvSpPr>
+          <p:cNvPr id="26" name="Text 24"/>
+          <p:cNvSpPr/>
+          <p:nvPr/>
+        </p:nvSpPr>
+        <p:spPr>
+          <a:xfrm>
+            <a:off x="8961120" y="5212080"/>
+            <a:ext cx="2286000" cy="365760"/>
+          </a:xfrm>
+          <a:prstGeom prst="rect">
+            <a:avLst/>
+          </a:prstGeom>
+          <a:noFill/>
+          <a:ln/>
+        </p:spPr>
+        <p:txBody>
+          <a:bodyPr wrap="square" lIns="0" tIns="0" rIns="0" bIns="0" rtlCol="0" anchor="ctr"/>
+          <a:lstStyle/>
+          <a:p>
+            <a:pPr algn="r" indent="0" marL="0">
+              <a:buNone/>
+            </a:pPr>
+            <a:r>
+              <a:rPr lang="en-US" sz="1100" dirty="0">
+                <a:solidFill>
+                  <a:srgbClr val="5C6672"/>
+                </a:solidFill>
+                <a:latin typeface="Calibri" pitchFamily="34" charset="0"/>
+                <a:ea typeface="Calibri" pitchFamily="34" charset="-122"/>
+                <a:cs typeface="Calibri" pitchFamily="34" charset="-120"/>
+              </a:rPr>
               <a:t>Local</a:t>
             </a:r>
-            <a:endParaRPr lang="en-US" sz="1200" dirty="0"/>
-          </a:p>
-        </p:txBody>
-      </p:sp>
-      <p:sp>
-        <p:nvSpPr>
-          <p:cNvPr id="23" name="Text 21"/>
-          <p:cNvSpPr/>
-          <p:nvPr/>
-        </p:nvSpPr>
-        <p:spPr>
-          <a:xfrm>
-            <a:off x="640080" y="6080760"/>
+            <a:endParaRPr lang="en-US" sz="1100" dirty="0"/>
+          </a:p>
+        </p:txBody>
+      </p:sp>
+      <p:sp>
+        <p:nvSpPr>
+          <p:cNvPr id="27" name="Text 25"/>
+          <p:cNvSpPr/>
+          <p:nvPr/>
+        </p:nvSpPr>
+        <p:spPr>
+          <a:xfrm>
+            <a:off x="640080" y="5989320"/>
             <a:ext cx="10881360" cy="365760"/>
           </a:xfrm>
           <a:prstGeom prst="rect">

</xml_diff>